<commit_message>
feat: rig and OLED photos on deck slides 5 and 13
</commit_message>
<xml_diff>
--- a/deliverables/VekariyaVishnuB00969091_Slides.pptx
+++ b/deliverables/VekariyaVishnuB00969091_Slides.pptx
@@ -5228,7 +5228,7 @@
         <p:spPr>
           <a:xfrm>
             <a:off x="1280160" y="1965960"/>
-            <a:ext cx="4663440" cy="384048"/>
+            <a:ext cx="3200400" cy="384048"/>
           </a:xfrm>
           <a:prstGeom prst="rect">
             <a:avLst/>
@@ -5266,8 +5266,8 @@
         </p:nvSpPr>
         <p:spPr>
           <a:xfrm>
-            <a:off x="6126480" y="1965960"/>
-            <a:ext cx="5486400" cy="384048"/>
+            <a:off x="4617720" y="1965960"/>
+            <a:ext cx="3794760" cy="384048"/>
           </a:xfrm>
           <a:prstGeom prst="rect">
             <a:avLst/>
@@ -5345,7 +5345,7 @@
         <p:spPr>
           <a:xfrm>
             <a:off x="1280160" y="2569464"/>
-            <a:ext cx="4663440" cy="384048"/>
+            <a:ext cx="3200400" cy="384048"/>
           </a:xfrm>
           <a:prstGeom prst="rect">
             <a:avLst/>
@@ -5383,8 +5383,8 @@
         </p:nvSpPr>
         <p:spPr>
           <a:xfrm>
-            <a:off x="6126480" y="2569464"/>
-            <a:ext cx="5486400" cy="384048"/>
+            <a:off x="4617720" y="2569464"/>
+            <a:ext cx="3794760" cy="384048"/>
           </a:xfrm>
           <a:prstGeom prst="rect">
             <a:avLst/>
@@ -5462,7 +5462,7 @@
         <p:spPr>
           <a:xfrm>
             <a:off x="1280160" y="3172968"/>
-            <a:ext cx="4663440" cy="384048"/>
+            <a:ext cx="3200400" cy="384048"/>
           </a:xfrm>
           <a:prstGeom prst="rect">
             <a:avLst/>
@@ -5500,8 +5500,8 @@
         </p:nvSpPr>
         <p:spPr>
           <a:xfrm>
-            <a:off x="6126480" y="3172968"/>
-            <a:ext cx="5486400" cy="384048"/>
+            <a:off x="4617720" y="3172968"/>
+            <a:ext cx="3794760" cy="384048"/>
           </a:xfrm>
           <a:prstGeom prst="rect">
             <a:avLst/>
@@ -5579,7 +5579,7 @@
         <p:spPr>
           <a:xfrm>
             <a:off x="1280160" y="3776472"/>
-            <a:ext cx="4663440" cy="384048"/>
+            <a:ext cx="3200400" cy="384048"/>
           </a:xfrm>
           <a:prstGeom prst="rect">
             <a:avLst/>
@@ -5617,8 +5617,8 @@
         </p:nvSpPr>
         <p:spPr>
           <a:xfrm>
-            <a:off x="6126480" y="3776472"/>
-            <a:ext cx="5486400" cy="384048"/>
+            <a:off x="4617720" y="3776472"/>
+            <a:ext cx="3794760" cy="384048"/>
           </a:xfrm>
           <a:prstGeom prst="rect">
             <a:avLst/>
@@ -5696,7 +5696,7 @@
         <p:spPr>
           <a:xfrm>
             <a:off x="1280160" y="4379976"/>
-            <a:ext cx="4663440" cy="384048"/>
+            <a:ext cx="3200400" cy="384048"/>
           </a:xfrm>
           <a:prstGeom prst="rect">
             <a:avLst/>
@@ -5734,8 +5734,8 @@
         </p:nvSpPr>
         <p:spPr>
           <a:xfrm>
-            <a:off x="6126480" y="4379976"/>
-            <a:ext cx="5486400" cy="384048"/>
+            <a:off x="4617720" y="4379976"/>
+            <a:ext cx="3794760" cy="384048"/>
           </a:xfrm>
           <a:prstGeom prst="rect">
             <a:avLst/>
@@ -5813,7 +5813,7 @@
         <p:spPr>
           <a:xfrm>
             <a:off x="1280160" y="4983480"/>
-            <a:ext cx="4663440" cy="384048"/>
+            <a:ext cx="3200400" cy="384048"/>
           </a:xfrm>
           <a:prstGeom prst="rect">
             <a:avLst/>
@@ -5851,8 +5851,8 @@
         </p:nvSpPr>
         <p:spPr>
           <a:xfrm>
-            <a:off x="6126480" y="4983480"/>
-            <a:ext cx="5486400" cy="384048"/>
+            <a:off x="4617720" y="4983480"/>
+            <a:ext cx="3794760" cy="384048"/>
           </a:xfrm>
           <a:prstGeom prst="rect">
             <a:avLst/>
@@ -5930,7 +5930,7 @@
         <p:spPr>
           <a:xfrm>
             <a:off x="1280160" y="5586984"/>
-            <a:ext cx="4663440" cy="384048"/>
+            <a:ext cx="3200400" cy="384048"/>
           </a:xfrm>
           <a:prstGeom prst="rect">
             <a:avLst/>
@@ -5968,8 +5968,8 @@
         </p:nvSpPr>
         <p:spPr>
           <a:xfrm>
-            <a:off x="6126480" y="5586984"/>
-            <a:ext cx="5486400" cy="384048"/>
+            <a:off x="4617720" y="5586984"/>
+            <a:ext cx="3794760" cy="384048"/>
           </a:xfrm>
           <a:prstGeom prst="rect">
             <a:avLst/>
@@ -5999,9 +5999,32 @@
           </a:p>
         </p:txBody>
       </p:sp>
-      <p:sp>
-        <p:nvSpPr>
-          <p:cNvPr id="25" name="Text 23"/>
+      <p:pic>
+        <p:nvPicPr>
+          <p:cNvPr id="25" name="Image 0" descr="C:\Users\vishn\OneDrive\Desktop\Edge Setup\LightGuide-Edge\reports\figures\rig\oled_optimal.jpeg">    </p:cNvPr>
+          <p:cNvPicPr>
+            <a:picLocks noChangeAspect="1"/>
+          </p:cNvPicPr>
+          <p:nvPr/>
+        </p:nvPicPr>
+        <p:blipFill>
+          <a:blip r:embed="rId1"/>
+          <a:srcRect l="0" r="0" t="0" b="0"/>
+          <a:stretch/>
+        </p:blipFill>
+        <p:spPr>
+          <a:xfrm>
+            <a:off x="8641080" y="1874520"/>
+            <a:ext cx="2999232" cy="3977640"/>
+          </a:xfrm>
+          <a:prstGeom prst="rect">
+            <a:avLst/>
+          </a:prstGeom>
+        </p:spPr>
+      </p:pic>
+      <p:sp>
+        <p:nvSpPr>
+          <p:cNvPr id="26" name="Text 23"/>
           <p:cNvSpPr/>
           <p:nvPr/>
         </p:nvSpPr>
@@ -8662,7 +8685,7 @@
         <p:spPr>
           <a:xfrm>
             <a:off x="548640" y="1536192"/>
-            <a:ext cx="11094415" cy="2788920"/>
+            <a:ext cx="6766560" cy="2788920"/>
           </a:xfrm>
           <a:prstGeom prst="rect">
             <a:avLst/>
@@ -8768,7 +8791,7 @@
         <p:spPr>
           <a:xfrm>
             <a:off x="548640" y="4480560"/>
-            <a:ext cx="11094415" cy="1847088"/>
+            <a:ext cx="6766560" cy="1847088"/>
           </a:xfrm>
           <a:prstGeom prst="roundRect">
             <a:avLst>
@@ -8795,7 +8818,7 @@
         <p:spPr>
           <a:xfrm>
             <a:off x="749808" y="4626864"/>
-            <a:ext cx="10692079" cy="310896"/>
+            <a:ext cx="6364224" cy="310896"/>
           </a:xfrm>
           <a:prstGeom prst="rect">
             <a:avLst/>
@@ -8834,7 +8857,7 @@
         <p:spPr>
           <a:xfrm>
             <a:off x="749808" y="4956048"/>
-            <a:ext cx="10692079" cy="1207008"/>
+            <a:ext cx="6364224" cy="1207008"/>
           </a:xfrm>
           <a:prstGeom prst="rect">
             <a:avLst/>
@@ -8861,6 +8884,68 @@
               <a:t>At 8 Hz consecutive samples are near-duplicates. A random split puts near-identical windows on both sides and reports a score that measures memorisation. Splitting by session — and grouping cross-validation by run — makes the test set answer the question that matters: does this work on a day it has not seen?</a:t>
             </a:r>
             <a:endParaRPr lang="en-US" sz="1200" dirty="0"/>
+          </a:p>
+        </p:txBody>
+      </p:sp>
+      <p:pic>
+        <p:nvPicPr>
+          <p:cNvPr id="8" name="Image 0" descr="C:\Users\vishn\OneDrive\Desktop\Edge Setup\LightGuide-Edge\reports\figures\rig\rig_overview.jpeg">    </p:cNvPr>
+          <p:cNvPicPr>
+            <a:picLocks noChangeAspect="1"/>
+          </p:cNvPicPr>
+          <p:nvPr/>
+        </p:nvPicPr>
+        <p:blipFill>
+          <a:blip r:embed="rId1"/>
+          <a:srcRect l="0" r="0" t="0" b="0"/>
+          <a:stretch/>
+        </p:blipFill>
+        <p:spPr>
+          <a:xfrm>
+            <a:off x="7543800" y="1536192"/>
+            <a:ext cx="4096512" cy="3749040"/>
+          </a:xfrm>
+          <a:prstGeom prst="rect">
+            <a:avLst/>
+          </a:prstGeom>
+        </p:spPr>
+      </p:pic>
+      <p:sp>
+        <p:nvSpPr>
+          <p:cNvPr id="9" name="Text 6"/>
+          <p:cNvSpPr/>
+          <p:nvPr/>
+        </p:nvSpPr>
+        <p:spPr>
+          <a:xfrm>
+            <a:off x="7543800" y="5376672"/>
+            <a:ext cx="4096512" cy="310896"/>
+          </a:xfrm>
+          <a:prstGeom prst="rect">
+            <a:avLst/>
+          </a:prstGeom>
+          <a:noFill/>
+          <a:ln/>
+        </p:spPr>
+        <p:txBody>
+          <a:bodyPr wrap="square" lIns="0" tIns="0" rIns="0" bIns="0" rtlCol="0" anchor="ctr"/>
+          <a:lstStyle/>
+          <a:p>
+            <a:pPr indent="0" marL="0">
+              <a:buNone/>
+            </a:pPr>
+            <a:r>
+              <a:rPr lang="en-US" sz="1000" i="1" dirty="0">
+                <a:solidFill>
+                  <a:srgbClr val="6E7687"/>
+                </a:solidFill>
+                <a:latin typeface="Calibri" pitchFamily="34" charset="0"/>
+                <a:ea typeface="Calibri" pitchFamily="34" charset="-122"/>
+                <a:cs typeface="Calibri" pitchFamily="34" charset="-120"/>
+              </a:rPr>
+              <a:t>The rig as used for collection: lamp and sensor board on one stand.</a:t>
+            </a:r>
+            <a:endParaRPr lang="en-US" sz="1000" dirty="0"/>
           </a:p>
         </p:txBody>
       </p:sp>

</xml_diff>